<commit_message>
Fix ERS deck layout issues and export the PDFs from PowerPoint
Remove the stray title-bar shapes from code windows, rejoin code lines that
were split inside a token, keep quote text clear of its rule, restyle four
flow labels and align two slides of the intro deck with the rest. Deck 06 now
states that Kova 0.3.2 loads AGENTS.md automatically.
</commit_message>
<xml_diff>
--- a/01 Elementi Razvoja Softvera/02 Prezentacije/PPTX/00_Osnovne_informacije.pptx
+++ b/01 Elementi Razvoja Softvera/02 Prezentacije/PPTX/00_Osnovne_informacije.pptx
@@ -6749,8 +6749,8 @@
         </p:nvSpPr>
         <p:spPr>
           <a:xfrm xmlns:a="http://schemas.openxmlformats.org/drawingml/2006/main">
-            <a:off x="731520" y="566928"/>
-            <a:ext cx="2286000" cy="201168"/>
+            <a:off x="685800" y="292608"/>
+            <a:ext cx="2011680" cy="164592"/>
           </a:xfrm>
           <a:prstGeom xmlns:a="http://schemas.openxmlformats.org/drawingml/2006/main" prst="rect">
             <a:avLst/>
@@ -6776,7 +6776,7 @@
               <a:buNone/>
             </a:pPr>
             <a:r>
-              <a:rPr sz="1000" b="0" i="0">
+              <a:rPr sz="900" b="0" i="0">
                 <a:solidFill>
                   <a:srgbClr val="3E5E7D"/>
                 </a:solidFill>
@@ -6805,7 +6805,7 @@
         </p:nvSpPr>
         <p:spPr>
           <a:xfrm xmlns:a="http://schemas.openxmlformats.org/drawingml/2006/main">
-            <a:off x="685800" y="827532"/>
+            <a:off x="685800" y="470916"/>
             <a:ext cx="10835640" cy="6858"/>
           </a:xfrm>
           <a:prstGeom xmlns:a="http://schemas.openxmlformats.org/drawingml/2006/main" prst="rect">
@@ -6860,7 +6860,7 @@
         </p:nvSpPr>
         <p:spPr>
           <a:xfrm xmlns:a="http://schemas.openxmlformats.org/drawingml/2006/main">
-            <a:off x="914400" y="1066800"/>
+            <a:off x="914400" y="960120"/>
             <a:ext cx="10363200" cy="457200"/>
           </a:xfrm>
           <a:prstGeom xmlns:a="http://schemas.openxmlformats.org/drawingml/2006/main" prst="rect">
@@ -6921,7 +6921,7 @@
         </p:nvSpPr>
         <p:spPr>
           <a:xfrm xmlns:a="http://schemas.openxmlformats.org/drawingml/2006/main">
-            <a:off x="914400" y="1676400"/>
+            <a:off x="914400" y="1569720"/>
             <a:ext cx="10363200" cy="400050"/>
           </a:xfrm>
           <a:prstGeom xmlns:a="http://schemas.openxmlformats.org/drawingml/2006/main" prst="rect">
@@ -6982,7 +6982,7 @@
         </p:nvSpPr>
         <p:spPr>
           <a:xfrm xmlns:a="http://schemas.openxmlformats.org/drawingml/2006/main">
-            <a:off x="914400" y="2343150"/>
+            <a:off x="914400" y="2236470"/>
             <a:ext cx="3219450" cy="2095500"/>
           </a:xfrm>
           <a:prstGeom xmlns:a="http://schemas.openxmlformats.org/drawingml/2006/main" prst="roundRect">
@@ -7017,7 +7017,7 @@
         </p:nvSpPr>
         <p:spPr>
           <a:xfrm xmlns:a="http://schemas.openxmlformats.org/drawingml/2006/main">
-            <a:off x="1085850" y="2514600"/>
+            <a:off x="1085850" y="2407920"/>
             <a:ext cx="400050" cy="285750"/>
           </a:xfrm>
           <a:prstGeom xmlns:a="http://schemas.openxmlformats.org/drawingml/2006/main" prst="roundRect">
@@ -7049,7 +7049,7 @@
         </p:nvSpPr>
         <p:spPr>
           <a:xfrm xmlns:a="http://schemas.openxmlformats.org/drawingml/2006/main">
-            <a:off x="1085850" y="2562225"/>
+            <a:off x="1085850" y="2455545"/>
             <a:ext cx="400050" cy="171450"/>
           </a:xfrm>
           <a:prstGeom xmlns:a="http://schemas.openxmlformats.org/drawingml/2006/main" prst="rect">
@@ -7110,7 +7110,7 @@
         </p:nvSpPr>
         <p:spPr>
           <a:xfrm xmlns:a="http://schemas.openxmlformats.org/drawingml/2006/main">
-            <a:off x="1085850" y="2952750"/>
+            <a:off x="1085850" y="2846070"/>
             <a:ext cx="2876550" cy="590550"/>
           </a:xfrm>
           <a:prstGeom xmlns:a="http://schemas.openxmlformats.org/drawingml/2006/main" prst="rect">
@@ -7171,7 +7171,7 @@
         </p:nvSpPr>
         <p:spPr>
           <a:xfrm xmlns:a="http://schemas.openxmlformats.org/drawingml/2006/main">
-            <a:off x="1085850" y="3676650"/>
+            <a:off x="1085850" y="3569970"/>
             <a:ext cx="2876550" cy="552450"/>
           </a:xfrm>
           <a:prstGeom xmlns:a="http://schemas.openxmlformats.org/drawingml/2006/main" prst="rect">
@@ -7232,7 +7232,7 @@
         </p:nvSpPr>
         <p:spPr>
           <a:xfrm xmlns:a="http://schemas.openxmlformats.org/drawingml/2006/main">
-            <a:off x="4486275" y="2343150"/>
+            <a:off x="4486275" y="2236470"/>
             <a:ext cx="3219450" cy="2095500"/>
           </a:xfrm>
           <a:prstGeom xmlns:a="http://schemas.openxmlformats.org/drawingml/2006/main" prst="roundRect">
@@ -7267,7 +7267,7 @@
         </p:nvSpPr>
         <p:spPr>
           <a:xfrm xmlns:a="http://schemas.openxmlformats.org/drawingml/2006/main">
-            <a:off x="4657725" y="2514600"/>
+            <a:off x="4657725" y="2407920"/>
             <a:ext cx="400050" cy="285750"/>
           </a:xfrm>
           <a:prstGeom xmlns:a="http://schemas.openxmlformats.org/drawingml/2006/main" prst="roundRect">
@@ -7299,7 +7299,7 @@
         </p:nvSpPr>
         <p:spPr>
           <a:xfrm xmlns:a="http://schemas.openxmlformats.org/drawingml/2006/main">
-            <a:off x="4657725" y="2562225"/>
+            <a:off x="4657725" y="2455545"/>
             <a:ext cx="400050" cy="171450"/>
           </a:xfrm>
           <a:prstGeom xmlns:a="http://schemas.openxmlformats.org/drawingml/2006/main" prst="rect">
@@ -7360,7 +7360,7 @@
         </p:nvSpPr>
         <p:spPr>
           <a:xfrm xmlns:a="http://schemas.openxmlformats.org/drawingml/2006/main">
-            <a:off x="4657725" y="2952750"/>
+            <a:off x="4657725" y="2846070"/>
             <a:ext cx="2876550" cy="590550"/>
           </a:xfrm>
           <a:prstGeom xmlns:a="http://schemas.openxmlformats.org/drawingml/2006/main" prst="rect">
@@ -7421,7 +7421,7 @@
         </p:nvSpPr>
         <p:spPr>
           <a:xfrm xmlns:a="http://schemas.openxmlformats.org/drawingml/2006/main">
-            <a:off x="4657725" y="3676650"/>
+            <a:off x="4657725" y="3569970"/>
             <a:ext cx="2876550" cy="552450"/>
           </a:xfrm>
           <a:prstGeom xmlns:a="http://schemas.openxmlformats.org/drawingml/2006/main" prst="rect">
@@ -7482,7 +7482,7 @@
         </p:nvSpPr>
         <p:spPr>
           <a:xfrm xmlns:a="http://schemas.openxmlformats.org/drawingml/2006/main">
-            <a:off x="8058150" y="2343150"/>
+            <a:off x="8058150" y="2236470"/>
             <a:ext cx="3219450" cy="2095500"/>
           </a:xfrm>
           <a:prstGeom xmlns:a="http://schemas.openxmlformats.org/drawingml/2006/main" prst="roundRect">
@@ -7517,7 +7517,7 @@
         </p:nvSpPr>
         <p:spPr>
           <a:xfrm xmlns:a="http://schemas.openxmlformats.org/drawingml/2006/main">
-            <a:off x="8229600" y="2514600"/>
+            <a:off x="8229600" y="2407920"/>
             <a:ext cx="400050" cy="285750"/>
           </a:xfrm>
           <a:prstGeom xmlns:a="http://schemas.openxmlformats.org/drawingml/2006/main" prst="roundRect">
@@ -7549,7 +7549,7 @@
         </p:nvSpPr>
         <p:spPr>
           <a:xfrm xmlns:a="http://schemas.openxmlformats.org/drawingml/2006/main">
-            <a:off x="8229600" y="2562225"/>
+            <a:off x="8229600" y="2455545"/>
             <a:ext cx="400050" cy="171450"/>
           </a:xfrm>
           <a:prstGeom xmlns:a="http://schemas.openxmlformats.org/drawingml/2006/main" prst="rect">
@@ -7610,7 +7610,7 @@
         </p:nvSpPr>
         <p:spPr>
           <a:xfrm xmlns:a="http://schemas.openxmlformats.org/drawingml/2006/main">
-            <a:off x="8229600" y="2952750"/>
+            <a:off x="8229600" y="2846070"/>
             <a:ext cx="2876550" cy="590550"/>
           </a:xfrm>
           <a:prstGeom xmlns:a="http://schemas.openxmlformats.org/drawingml/2006/main" prst="rect">
@@ -7671,7 +7671,7 @@
         </p:nvSpPr>
         <p:spPr>
           <a:xfrm xmlns:a="http://schemas.openxmlformats.org/drawingml/2006/main">
-            <a:off x="8229600" y="3676650"/>
+            <a:off x="8229600" y="3569970"/>
             <a:ext cx="2876550" cy="552450"/>
           </a:xfrm>
           <a:prstGeom xmlns:a="http://schemas.openxmlformats.org/drawingml/2006/main" prst="rect">
@@ -7732,7 +7732,7 @@
         </p:nvSpPr>
         <p:spPr>
           <a:xfrm xmlns:a="http://schemas.openxmlformats.org/drawingml/2006/main">
-            <a:off x="914400" y="4810125"/>
+            <a:off x="914400" y="4703445"/>
             <a:ext cx="10363200" cy="866775"/>
           </a:xfrm>
           <a:prstGeom xmlns:a="http://schemas.openxmlformats.org/drawingml/2006/main" prst="roundRect">
@@ -7767,7 +7767,7 @@
         </p:nvSpPr>
         <p:spPr>
           <a:xfrm xmlns:a="http://schemas.openxmlformats.org/drawingml/2006/main">
-            <a:off x="1085850" y="4981575"/>
+            <a:off x="1085850" y="4874895"/>
             <a:ext cx="57150" cy="523875"/>
           </a:xfrm>
           <a:prstGeom xmlns:a="http://schemas.openxmlformats.org/drawingml/2006/main" prst="roundRect">
@@ -7799,7 +7799,7 @@
         </p:nvSpPr>
         <p:spPr>
           <a:xfrm xmlns:a="http://schemas.openxmlformats.org/drawingml/2006/main">
-            <a:off x="1333500" y="4933950"/>
+            <a:off x="1333500" y="4827270"/>
             <a:ext cx="2190750" cy="190500"/>
           </a:xfrm>
           <a:prstGeom xmlns:a="http://schemas.openxmlformats.org/drawingml/2006/main" prst="rect">
@@ -7860,7 +7860,7 @@
         </p:nvSpPr>
         <p:spPr>
           <a:xfrm xmlns:a="http://schemas.openxmlformats.org/drawingml/2006/main">
-            <a:off x="1333500" y="5219700"/>
+            <a:off x="1333500" y="5113020"/>
             <a:ext cx="9601200" cy="419100"/>
           </a:xfrm>
           <a:prstGeom xmlns:a="http://schemas.openxmlformats.org/drawingml/2006/main" prst="rect">
@@ -7907,53 +7907,48 @@
       </p:sp>
       <p:sp>
         <p:nvSpPr>
-          <p:cNvPr id="25" name="">
-            <a:extLst xmlns:a="http://schemas.openxmlformats.org/drawingml/2006/main">
-              <a:ext uri="{FF2B5EF4-FFF2-40B4-BE49-F238E27FC236}">
-                <a16:creationId xmlns:a16="http://schemas.microsoft.com/office/drawing/2014/main" id="{2859B476-FF65-422B-9D03-BE815E22B73E}"/>
-              </a:ext>
-            </a:extLst>
-          </p:cNvPr>
-          <p:cNvSpPr>
-            <a:spLocks xmlns:a="http://schemas.openxmlformats.org/drawingml/2006/main" noGrp="1"/>
-          </p:cNvSpPr>
-          <p:nvPr/>
-        </p:nvSpPr>
-        <p:spPr>
-          <a:xfrm xmlns:a="http://schemas.openxmlformats.org/drawingml/2006/main">
-            <a:off x="11353800" y="6419850"/>
-            <a:ext cx="323850" cy="171450"/>
+          <p:cNvPr id="25" name="TextBox 24">
+            <a:extLst xmlns:a="http://schemas.openxmlformats.org/drawingml/2006/main">
+              <a:ext uri="{FF2B5EF4-FFF2-40B4-BE49-F238E27FC236}">
+                <a16:creationId xmlns:a16="http://schemas.microsoft.com/office/drawing/2014/main" id="{F9CE6272-A4AB-4A7F-8B24-29BDF0EE307E}"/>
+              </a:ext>
+            </a:extLst>
+          </p:cNvPr>
+          <p:cNvSpPr>
+            <a:spLocks xmlns:a="http://schemas.openxmlformats.org/drawingml/2006/main" noGrp="1"/>
+          </p:cNvSpPr>
+          <p:nvPr/>
+        </p:nvSpPr>
+        <p:spPr>
+          <a:xfrm xmlns:a="http://schemas.openxmlformats.org/drawingml/2006/main">
+            <a:off x="11475720" y="6336792"/>
+            <a:ext cx="365760" cy="201168"/>
           </a:xfrm>
           <a:prstGeom xmlns:a="http://schemas.openxmlformats.org/drawingml/2006/main" prst="rect">
             <a:avLst/>
           </a:prstGeom>
           <a:noFill xmlns:a="http://schemas.openxmlformats.org/drawingml/2006/main"/>
-          <a:ln xmlns:a="http://schemas.openxmlformats.org/drawingml/2006/main" w="0">
-            <a:noFill/>
-          </a:ln>
         </p:spPr>
         <p:txBody>
           <a:bodyPr xmlns:a="http://schemas.openxmlformats.org/drawingml/2006/main" wrap="square" lIns="0" tIns="0" rIns="0" bIns="0" anchor="t">
-            <a:normAutofit fontScale="100000"/>
+            <a:spAutoFit/>
           </a:bodyPr>
           <a:lstStyle xmlns:a="http://schemas.openxmlformats.org/drawingml/2006/main"/>
           <a:p xmlns:a="http://schemas.openxmlformats.org/drawingml/2006/main">
             <a:pPr algn="r">
               <a:lnSpc>
-                <a:spcPct val="100000"/>
-              </a:lnSpc>
-              <a:buNone/>
-              <a:defRPr sz="975" b="0">
-                <a:solidFill>
-                  <a:srgbClr val="1A202C"/>
-                </a:solidFill>
-                <a:latin typeface="Aptos"/>
-                <a:ea typeface="Aptos"/>
-                <a:cs typeface="Aptos"/>
-              </a:defRPr>
-            </a:pPr>
-            <a:r>
-              <a:rPr sz="975" b="0">
+                <a:spcPct val="110000"/>
+              </a:lnSpc>
+              <a:spcBef>
+                <a:spcPts val="0"/>
+              </a:spcBef>
+              <a:spcAft>
+                <a:spcPts val="0"/>
+              </a:spcAft>
+              <a:buNone/>
+            </a:pPr>
+            <a:r>
+              <a:rPr sz="1200" b="0" i="0">
                 <a:solidFill>
                   <a:srgbClr val="87919C"/>
                 </a:solidFill>
@@ -8011,8 +8006,8 @@
         </p:nvSpPr>
         <p:spPr>
           <a:xfrm xmlns:a="http://schemas.openxmlformats.org/drawingml/2006/main">
-            <a:off x="731520" y="566928"/>
-            <a:ext cx="2286000" cy="201168"/>
+            <a:off x="685800" y="292608"/>
+            <a:ext cx="2011680" cy="164592"/>
           </a:xfrm>
           <a:prstGeom xmlns:a="http://schemas.openxmlformats.org/drawingml/2006/main" prst="rect">
             <a:avLst/>
@@ -8038,7 +8033,7 @@
               <a:buNone/>
             </a:pPr>
             <a:r>
-              <a:rPr sz="1000" b="0" i="0">
+              <a:rPr sz="900" b="0" i="0">
                 <a:solidFill>
                   <a:srgbClr val="3E5E7D"/>
                 </a:solidFill>
@@ -8067,7 +8062,7 @@
         </p:nvSpPr>
         <p:spPr>
           <a:xfrm xmlns:a="http://schemas.openxmlformats.org/drawingml/2006/main">
-            <a:off x="685800" y="827532"/>
+            <a:off x="685800" y="470916"/>
             <a:ext cx="10835640" cy="6858"/>
           </a:xfrm>
           <a:prstGeom xmlns:a="http://schemas.openxmlformats.org/drawingml/2006/main" prst="rect">
@@ -8122,7 +8117,7 @@
         </p:nvSpPr>
         <p:spPr>
           <a:xfrm xmlns:a="http://schemas.openxmlformats.org/drawingml/2006/main">
-            <a:off x="914400" y="1066800"/>
+            <a:off x="914400" y="960120"/>
             <a:ext cx="10363200" cy="457200"/>
           </a:xfrm>
           <a:prstGeom xmlns:a="http://schemas.openxmlformats.org/drawingml/2006/main" prst="rect">
@@ -8183,7 +8178,7 @@
         </p:nvSpPr>
         <p:spPr>
           <a:xfrm xmlns:a="http://schemas.openxmlformats.org/drawingml/2006/main">
-            <a:off x="914400" y="1676400"/>
+            <a:off x="914400" y="1569720"/>
             <a:ext cx="10363200" cy="400050"/>
           </a:xfrm>
           <a:prstGeom xmlns:a="http://schemas.openxmlformats.org/drawingml/2006/main" prst="rect">
@@ -8244,7 +8239,7 @@
         </p:nvSpPr>
         <p:spPr>
           <a:xfrm xmlns:a="http://schemas.openxmlformats.org/drawingml/2006/main">
-            <a:off x="914400" y="2343150"/>
+            <a:off x="914400" y="2236470"/>
             <a:ext cx="3219450" cy="2095500"/>
           </a:xfrm>
           <a:prstGeom xmlns:a="http://schemas.openxmlformats.org/drawingml/2006/main" prst="roundRect">
@@ -8279,7 +8274,7 @@
         </p:nvSpPr>
         <p:spPr>
           <a:xfrm xmlns:a="http://schemas.openxmlformats.org/drawingml/2006/main">
-            <a:off x="1085850" y="2514600"/>
+            <a:off x="1085850" y="2407920"/>
             <a:ext cx="400050" cy="285750"/>
           </a:xfrm>
           <a:prstGeom xmlns:a="http://schemas.openxmlformats.org/drawingml/2006/main" prst="roundRect">
@@ -8311,7 +8306,7 @@
         </p:nvSpPr>
         <p:spPr>
           <a:xfrm xmlns:a="http://schemas.openxmlformats.org/drawingml/2006/main">
-            <a:off x="1085850" y="2562225"/>
+            <a:off x="1085850" y="2455545"/>
             <a:ext cx="400050" cy="171450"/>
           </a:xfrm>
           <a:prstGeom xmlns:a="http://schemas.openxmlformats.org/drawingml/2006/main" prst="rect">
@@ -8372,7 +8367,7 @@
         </p:nvSpPr>
         <p:spPr>
           <a:xfrm xmlns:a="http://schemas.openxmlformats.org/drawingml/2006/main">
-            <a:off x="1085850" y="2952750"/>
+            <a:off x="1085850" y="2846070"/>
             <a:ext cx="2876550" cy="590550"/>
           </a:xfrm>
           <a:prstGeom xmlns:a="http://schemas.openxmlformats.org/drawingml/2006/main" prst="rect">
@@ -8433,7 +8428,7 @@
         </p:nvSpPr>
         <p:spPr>
           <a:xfrm xmlns:a="http://schemas.openxmlformats.org/drawingml/2006/main">
-            <a:off x="1085850" y="3676650"/>
+            <a:off x="1085850" y="3569970"/>
             <a:ext cx="2876550" cy="552450"/>
           </a:xfrm>
           <a:prstGeom xmlns:a="http://schemas.openxmlformats.org/drawingml/2006/main" prst="rect">
@@ -8494,7 +8489,7 @@
         </p:nvSpPr>
         <p:spPr>
           <a:xfrm xmlns:a="http://schemas.openxmlformats.org/drawingml/2006/main">
-            <a:off x="4486275" y="2343150"/>
+            <a:off x="4486275" y="2236470"/>
             <a:ext cx="3219450" cy="2095500"/>
           </a:xfrm>
           <a:prstGeom xmlns:a="http://schemas.openxmlformats.org/drawingml/2006/main" prst="roundRect">
@@ -8529,7 +8524,7 @@
         </p:nvSpPr>
         <p:spPr>
           <a:xfrm xmlns:a="http://schemas.openxmlformats.org/drawingml/2006/main">
-            <a:off x="4657725" y="2514600"/>
+            <a:off x="4657725" y="2407920"/>
             <a:ext cx="400050" cy="285750"/>
           </a:xfrm>
           <a:prstGeom xmlns:a="http://schemas.openxmlformats.org/drawingml/2006/main" prst="roundRect">
@@ -8561,7 +8556,7 @@
         </p:nvSpPr>
         <p:spPr>
           <a:xfrm xmlns:a="http://schemas.openxmlformats.org/drawingml/2006/main">
-            <a:off x="4657725" y="2562225"/>
+            <a:off x="4657725" y="2455545"/>
             <a:ext cx="400050" cy="171450"/>
           </a:xfrm>
           <a:prstGeom xmlns:a="http://schemas.openxmlformats.org/drawingml/2006/main" prst="rect">
@@ -8622,7 +8617,7 @@
         </p:nvSpPr>
         <p:spPr>
           <a:xfrm xmlns:a="http://schemas.openxmlformats.org/drawingml/2006/main">
-            <a:off x="4657725" y="2952750"/>
+            <a:off x="4657725" y="2846070"/>
             <a:ext cx="2876550" cy="590550"/>
           </a:xfrm>
           <a:prstGeom xmlns:a="http://schemas.openxmlformats.org/drawingml/2006/main" prst="rect">
@@ -8683,7 +8678,7 @@
         </p:nvSpPr>
         <p:spPr>
           <a:xfrm xmlns:a="http://schemas.openxmlformats.org/drawingml/2006/main">
-            <a:off x="4657725" y="3676650"/>
+            <a:off x="4657725" y="3569970"/>
             <a:ext cx="2876550" cy="552450"/>
           </a:xfrm>
           <a:prstGeom xmlns:a="http://schemas.openxmlformats.org/drawingml/2006/main" prst="rect">
@@ -8744,7 +8739,7 @@
         </p:nvSpPr>
         <p:spPr>
           <a:xfrm xmlns:a="http://schemas.openxmlformats.org/drawingml/2006/main">
-            <a:off x="8058150" y="2343150"/>
+            <a:off x="8058150" y="2236470"/>
             <a:ext cx="3219450" cy="2095500"/>
           </a:xfrm>
           <a:prstGeom xmlns:a="http://schemas.openxmlformats.org/drawingml/2006/main" prst="roundRect">
@@ -8779,7 +8774,7 @@
         </p:nvSpPr>
         <p:spPr>
           <a:xfrm xmlns:a="http://schemas.openxmlformats.org/drawingml/2006/main">
-            <a:off x="8229600" y="2514600"/>
+            <a:off x="8229600" y="2407920"/>
             <a:ext cx="400050" cy="285750"/>
           </a:xfrm>
           <a:prstGeom xmlns:a="http://schemas.openxmlformats.org/drawingml/2006/main" prst="roundRect">
@@ -8811,7 +8806,7 @@
         </p:nvSpPr>
         <p:spPr>
           <a:xfrm xmlns:a="http://schemas.openxmlformats.org/drawingml/2006/main">
-            <a:off x="8229600" y="2562225"/>
+            <a:off x="8229600" y="2455545"/>
             <a:ext cx="400050" cy="171450"/>
           </a:xfrm>
           <a:prstGeom xmlns:a="http://schemas.openxmlformats.org/drawingml/2006/main" prst="rect">
@@ -8872,7 +8867,7 @@
         </p:nvSpPr>
         <p:spPr>
           <a:xfrm xmlns:a="http://schemas.openxmlformats.org/drawingml/2006/main">
-            <a:off x="8229600" y="2952750"/>
+            <a:off x="8229600" y="2846070"/>
             <a:ext cx="2876550" cy="590550"/>
           </a:xfrm>
           <a:prstGeom xmlns:a="http://schemas.openxmlformats.org/drawingml/2006/main" prst="rect">
@@ -8933,7 +8928,7 @@
         </p:nvSpPr>
         <p:spPr>
           <a:xfrm xmlns:a="http://schemas.openxmlformats.org/drawingml/2006/main">
-            <a:off x="8229600" y="3676650"/>
+            <a:off x="8229600" y="3569970"/>
             <a:ext cx="2876550" cy="552450"/>
           </a:xfrm>
           <a:prstGeom xmlns:a="http://schemas.openxmlformats.org/drawingml/2006/main" prst="rect">
@@ -8994,7 +8989,7 @@
         </p:nvSpPr>
         <p:spPr>
           <a:xfrm xmlns:a="http://schemas.openxmlformats.org/drawingml/2006/main">
-            <a:off x="914400" y="4810125"/>
+            <a:off x="914400" y="4703445"/>
             <a:ext cx="10363200" cy="866775"/>
           </a:xfrm>
           <a:prstGeom xmlns:a="http://schemas.openxmlformats.org/drawingml/2006/main" prst="roundRect">
@@ -9029,7 +9024,7 @@
         </p:nvSpPr>
         <p:spPr>
           <a:xfrm xmlns:a="http://schemas.openxmlformats.org/drawingml/2006/main">
-            <a:off x="1085850" y="4981575"/>
+            <a:off x="1085850" y="4874895"/>
             <a:ext cx="57150" cy="523875"/>
           </a:xfrm>
           <a:prstGeom xmlns:a="http://schemas.openxmlformats.org/drawingml/2006/main" prst="roundRect">
@@ -9061,7 +9056,7 @@
         </p:nvSpPr>
         <p:spPr>
           <a:xfrm xmlns:a="http://schemas.openxmlformats.org/drawingml/2006/main">
-            <a:off x="1333500" y="4933950"/>
+            <a:off x="1333500" y="4827270"/>
             <a:ext cx="2190750" cy="190500"/>
           </a:xfrm>
           <a:prstGeom xmlns:a="http://schemas.openxmlformats.org/drawingml/2006/main" prst="rect">
@@ -9122,7 +9117,7 @@
         </p:nvSpPr>
         <p:spPr>
           <a:xfrm xmlns:a="http://schemas.openxmlformats.org/drawingml/2006/main">
-            <a:off x="1333500" y="5219700"/>
+            <a:off x="1333500" y="5113020"/>
             <a:ext cx="9601200" cy="419100"/>
           </a:xfrm>
           <a:prstGeom xmlns:a="http://schemas.openxmlformats.org/drawingml/2006/main" prst="rect">
@@ -9169,53 +9164,48 @@
       </p:sp>
       <p:sp>
         <p:nvSpPr>
-          <p:cNvPr id="25" name="">
-            <a:extLst xmlns:a="http://schemas.openxmlformats.org/drawingml/2006/main">
-              <a:ext uri="{FF2B5EF4-FFF2-40B4-BE49-F238E27FC236}">
-                <a16:creationId xmlns:a16="http://schemas.microsoft.com/office/drawing/2014/main" id="{2859B476-FF65-422B-9D03-BE815E22B73E}"/>
-              </a:ext>
-            </a:extLst>
-          </p:cNvPr>
-          <p:cNvSpPr>
-            <a:spLocks xmlns:a="http://schemas.openxmlformats.org/drawingml/2006/main" noGrp="1"/>
-          </p:cNvSpPr>
-          <p:nvPr/>
-        </p:nvSpPr>
-        <p:spPr>
-          <a:xfrm xmlns:a="http://schemas.openxmlformats.org/drawingml/2006/main">
-            <a:off x="11353800" y="6419850"/>
-            <a:ext cx="323850" cy="171450"/>
+          <p:cNvPr id="25" name="TextBox 24">
+            <a:extLst xmlns:a="http://schemas.openxmlformats.org/drawingml/2006/main">
+              <a:ext uri="{FF2B5EF4-FFF2-40B4-BE49-F238E27FC236}">
+                <a16:creationId xmlns:a16="http://schemas.microsoft.com/office/drawing/2014/main" id="{F9CE6272-A4AB-4A7F-8B24-29BDF0EE307E}"/>
+              </a:ext>
+            </a:extLst>
+          </p:cNvPr>
+          <p:cNvSpPr>
+            <a:spLocks xmlns:a="http://schemas.openxmlformats.org/drawingml/2006/main" noGrp="1"/>
+          </p:cNvSpPr>
+          <p:nvPr/>
+        </p:nvSpPr>
+        <p:spPr>
+          <a:xfrm xmlns:a="http://schemas.openxmlformats.org/drawingml/2006/main">
+            <a:off x="11475720" y="6336792"/>
+            <a:ext cx="365760" cy="201168"/>
           </a:xfrm>
           <a:prstGeom xmlns:a="http://schemas.openxmlformats.org/drawingml/2006/main" prst="rect">
             <a:avLst/>
           </a:prstGeom>
           <a:noFill xmlns:a="http://schemas.openxmlformats.org/drawingml/2006/main"/>
-          <a:ln xmlns:a="http://schemas.openxmlformats.org/drawingml/2006/main" w="0">
-            <a:noFill/>
-          </a:ln>
         </p:spPr>
         <p:txBody>
           <a:bodyPr xmlns:a="http://schemas.openxmlformats.org/drawingml/2006/main" wrap="square" lIns="0" tIns="0" rIns="0" bIns="0" anchor="t">
-            <a:normAutofit fontScale="100000"/>
+            <a:spAutoFit/>
           </a:bodyPr>
           <a:lstStyle xmlns:a="http://schemas.openxmlformats.org/drawingml/2006/main"/>
           <a:p xmlns:a="http://schemas.openxmlformats.org/drawingml/2006/main">
             <a:pPr algn="r">
               <a:lnSpc>
-                <a:spcPct val="100000"/>
-              </a:lnSpc>
-              <a:buNone/>
-              <a:defRPr sz="975" b="0">
-                <a:solidFill>
-                  <a:srgbClr val="1A202C"/>
-                </a:solidFill>
-                <a:latin typeface="Aptos"/>
-                <a:ea typeface="Aptos"/>
-                <a:cs typeface="Aptos"/>
-              </a:defRPr>
-            </a:pPr>
-            <a:r>
-              <a:rPr sz="975" b="0">
+                <a:spcPct val="110000"/>
+              </a:lnSpc>
+              <a:spcBef>
+                <a:spcPts val="0"/>
+              </a:spcBef>
+              <a:spcAft>
+                <a:spcPts val="0"/>
+              </a:spcAft>
+              <a:buNone/>
+            </a:pPr>
+            <a:r>
+              <a:rPr sz="1200" b="0" i="0">
                 <a:solidFill>
                   <a:srgbClr val="87919C"/>
                 </a:solidFill>

</xml_diff>